<commit_message>
Refactor DeBERTa-v3 pipeline: update metrics, improve documentation, and adjust presentation content
- Updated the PDF generation to reflect pending results for Model 4 and clarified the assigned role description.
- Revised the notebook generator to emphasize that it only documents the pipeline without producing metrics unless a valid results file exists.
- Modified presentation slides to indicate that historical metrics are not valid and that the new pipeline requires a full run for final results.
- Enhanced the run_deberta script to implement a Siamese architecture with improved training and evaluation processes, including better handling of metrics and predictions.
</commit_message>
<xml_diff>
--- a/presentacion_proyecto2_lmsys.pptx
+++ b/presentacion_proyecto2_lmsys.pptx
@@ -5137,15 +5137,15 @@
               </a:defRPr>
             </a:pPr>
             <a:r>
-              <a:t>  - Al calibrar la formulación siamés latente sin fine-tuning de 30 horas, el modelo obtiene Log Loss = 1.0886 y Accuracy = 39.96% en Test.</a:t>
+              <a:t>  - El pipeline histórico no hacía fine-tuning y sus métricas no deben presentarse como resultado final.</a:t>
             </a:r>
             <a:br/>
             <a:r>
-              <a:t>  - Supera la línea base trivial (1.0972), pero evidencia que un transformer requiere épocas completas de ajuste de pesos en sus 12 capas para superar a XGBoost.</a:t>
+              <a:t>  - Ahora existe un pipeline real en src/run_deberta.py que guarda checkpoint, historial y predicciones.</a:t>
             </a:r>
             <a:br/>
             <a:r>
-              <a:t>  - Swap bias obtenido: 0.000000 (perfecto).</a:t>
+              <a:t>  - La corrida limitada actual es solo un smoke test; la métrica final requiere ejecutar full-run con las particiones oficiales.</a:t>
             </a:r>
           </a:p>
         </p:txBody>
@@ -6274,7 +6274,7 @@
                         </a:defRPr>
                       </a:pPr>
                       <a:r>
-                        <a:t>1.0886</a:t>
+                        <a:t>Pendiente</a:t>
                       </a:r>
                     </a:p>
                   </a:txBody>
@@ -6297,7 +6297,7 @@
                         </a:defRPr>
                       </a:pPr>
                       <a:r>
-                        <a:t>39.96%</a:t>
+                        <a:t>Pendiente</a:t>
                       </a:r>
                     </a:p>
                   </a:txBody>
@@ -6320,36 +6320,13 @@
                         </a:defRPr>
                       </a:pPr>
                       <a:r>
-                        <a:t>0.3551</a:t>
+                        <a:t>Pendiente</a:t>
                       </a:r>
                     </a:p>
                   </a:txBody>
                   <a:tcPr>
                     <a:solidFill>
                       <a:srgbClr val="FFFFFF"/>
-                    </a:solidFill>
-                  </a:tcPr>
-                </a:tc>
-                <a:tc>
-                  <a:txBody>
-                    <a:bodyPr/>
-                    <a:lstStyle/>
-                    <a:p>
-                      <a:pPr algn="ctr">
-                        <a:defRPr sz="1050" b="1">
-                          <a:solidFill>
-                            <a:srgbClr val="0F172A"/>
-                          </a:solidFill>
-                        </a:defRPr>
-                      </a:pPr>
-                      <a:r>
-                        <a:t>0.0000 ★</a:t>
-                      </a:r>
-                    </a:p>
-                  </a:txBody>
-                  <a:tcPr>
-                    <a:solidFill>
-                      <a:srgbClr val="ECFDF5"/>
                     </a:solidFill>
                   </a:tcPr>
                 </a:tc>
@@ -6366,7 +6343,30 @@
                         </a:defRPr>
                       </a:pPr>
                       <a:r>
-                        <a:t>23.6 min</a:t>
+                        <a:t>Por validar</a:t>
+                      </a:r>
+                    </a:p>
+                  </a:txBody>
+                  <a:tcPr>
+                    <a:solidFill>
+                      <a:srgbClr val="FFFFFF"/>
+                    </a:solidFill>
+                  </a:tcPr>
+                </a:tc>
+                <a:tc>
+                  <a:txBody>
+                    <a:bodyPr/>
+                    <a:lstStyle/>
+                    <a:p>
+                      <a:pPr algn="ctr">
+                        <a:defRPr sz="1050">
+                          <a:solidFill>
+                            <a:srgbClr val="0F172A"/>
+                          </a:solidFill>
+                        </a:defRPr>
+                      </a:pPr>
+                      <a:r>
+                        <a:t>Por validar</a:t>
                       </a:r>
                     </a:p>
                   </a:txBody>
@@ -6456,7 +6456,7 @@
               </a:defRPr>
             </a:pPr>
             <a:r>
-              <a:t>Veredicto Técnico Final: XGBoost con rating Bradley-Terry y rasgos de estilo es el modelo con mejor compromiso costo-beneficio (Log Loss 0.9909 en 24 segundos). El diseño siamés de DeBERTa demuestra la máxima consistencia posicional (Swap Bias = 0), y los Embeddings logran la mayor detección de empates (F1 Tie = 0.356).</a:t>
+              <a:t>Veredicto Técnico Provisional: XGBoost con rating Bradley-Terry y rasgos de estilo es el mejor resultado reproducible disponible. DeBERTa tiene un pipeline real, pero su corrida completa todavía debe ejecutarse; por eso no se le asigna una métrica final ni se afirma que gane.</a:t>
             </a:r>
           </a:p>
         </p:txBody>

</xml_diff>